<commit_message>
Proofread fineweb with Japanese proofreading skill
</commit_message>
<xml_diff>
--- a/slides/datasets-in-10-minutes-fineweb.pptx
+++ b/slides/datasets-in-10-minutes-fineweb.pptx
@@ -9395,7 +9395,7 @@
                 <a:ea typeface="Noto Sans CJK JP"/>
                 <a:cs typeface="Noto Sans"/>
               </a:rPr>
-              <a:t>そこで、反復の多さや書式など、別の品質規則を重ねて適用する。</a:t>
+              <a:t>その上で、反復の多さや書式など、別の品質規則を重ねて適用する。</a:t>
             </a:r>
           </a:p>
         </p:txBody>
@@ -9622,7 +9622,7 @@
                 <a:ea typeface="Noto Sans CJK JP"/>
                 <a:cs typeface="Noto Sans"/>
               </a:rPr>
-              <a:t>既存のGopher・C4の規則を調整し、さらにFineWeb固有の規則を追加する。各規則の効果を学習実験で比べた。</a:t>
+              <a:t>既存のGopher・C4の規則を調整し、さらにFineWeb固有の規則を追加した。各規則の効果を学習実験で比べた。</a:t>
             </a:r>
           </a:p>
         </p:txBody>
@@ -10683,7 +10683,7 @@
                 <a:ea typeface="Noto Sans CJK JP"/>
                 <a:cs typeface="Noto Sans"/>
               </a:rPr>
-              <a:t>FineWebの公開範囲とトークン数</a:t>
+              <a:t>FineWebの公開区分とトークン数</a:t>
             </a:r>
           </a:p>
         </p:txBody>
@@ -10776,7 +10776,7 @@
                           <a:ea typeface="Noto Sans CJK JP"/>
                           <a:cs typeface="Noto Sans"/>
                         </a:rPr>
-                        <a:t>範囲</a:t>
+                        <a:t>区分</a:t>
                       </a:r>
                     </a:p>
                   </a:txBody>
@@ -12311,7 +12311,7 @@
                 <a:ea typeface="Noto Sans CJK JP"/>
                 <a:cs typeface="Noto Sans"/>
               </a:rPr>
-              <a:t>[2] FineWeb2公式リポジトリ  </a:t>
+              <a:t/>
             </a:r>
             <a:r>
               <a:rPr sz="800" b="0" lang="en-US">
@@ -12323,7 +12323,7 @@
                 <a:cs typeface="Noto Sans"/>
                 <a:hlinkClick r:id="rId3"/>
               </a:rPr>
-              <a:t>https://github.com/huggingface/fineweb-2</a:t>
+              <a:t/>
             </a:r>
           </a:p>
         </p:txBody>
@@ -13045,7 +13045,7 @@
                 <a:ea typeface="Noto Sans CJK JP"/>
                 <a:cs typeface="Noto Sans"/>
               </a:rPr>
-              <a:t>処理の比較は主に約1.8Bパラメータ・約28Bトークン。大きな比較は350Bトークンを使う。</a:t>
+              <a:t>処理の比較は主に約1.8Bパラメータ・約28Bトークンで行い、大規模な比較には350Bトークンを使う。</a:t>
             </a:r>
           </a:p>
         </p:txBody>
@@ -15228,7 +15228,7 @@
                           <a:ea typeface="Noto Sans CJK JP"/>
                           <a:cs typeface="Noto Sans"/>
                         </a:rPr>
-                        <a:t>原著v2の比較</a:t>
+                        <a:t>評価指標</a:t>
                       </a:r>
                     </a:p>
                   </a:txBody>
@@ -15683,7 +15683,7 @@
                 <a:ea typeface="Noto Sans CJK JP"/>
                 <a:cs typeface="Noto Sans"/>
               </a:rPr>
-              <a:t>原著v2の1.71Bモデル・350Bトークンの比較 [1]。</a:t>
+              <a:t>原著v2における1.71Bモデル・350Bトークンでの比較 [1]。</a:t>
             </a:r>
           </a:p>
         </p:txBody>
@@ -15884,7 +15884,7 @@
                           <a:ea typeface="Noto Sans CJK JP"/>
                           <a:cs typeface="Noto Sans"/>
                         </a:rPr>
-                        <a:t>原著v2の構成</a:t>
+                        <a:t>構成項目</a:t>
                       </a:r>
                     </a:p>
                   </a:txBody>
@@ -16080,7 +16080,7 @@
                           <a:ea typeface="Noto Sans CJK JP"/>
                           <a:cs typeface="Noto Sans"/>
                         </a:rPr>
-                        <a:t>文脈長 / 区切り方</a:t>
+                        <a:t>文脈長 / トークナイザー</a:t>
                       </a:r>
                     </a:p>
                   </a:txBody>
@@ -17061,7 +17061,7 @@
                 <a:ea typeface="Noto Sans CJK JP"/>
                 <a:cs typeface="Noto Sans"/>
               </a:rPr>
-              <a:t>図18は構成比の差の絶対値が0.5ポイント以上の39分類を示す [1]。</a:t>
+              <a:t>原著の図18は、構成比の差の絶対値が0.5ポイント以上の39分類を示す [1]。</a:t>
             </a:r>
           </a:p>
         </p:txBody>
@@ -17504,7 +17504,7 @@
                           <a:ea typeface="Noto Sans CJK JP"/>
                           <a:cs typeface="Noto Sans"/>
                         </a:rPr>
-                        <a:t>FineWebとの関係</a:t>
+                        <a:t>開発目的・位置付け</a:t>
                       </a:r>
                     </a:p>
                   </a:txBody>
@@ -18066,7 +18066,7 @@
                           <a:ea typeface="Noto Sans CJK JP"/>
                           <a:cs typeface="Noto Sans"/>
                         </a:rPr>
-                        <a:t>1,000超の言語へ処理を適応</a:t>
+                        <a:t>1,000超の言語へ処理を適用</a:t>
                       </a:r>
                     </a:p>
                   </a:txBody>
@@ -21176,7 +21176,7 @@
                           <a:ea typeface="Noto Sans CJK JP"/>
                           <a:cs typeface="Noto Sans"/>
                         </a:rPr>
-                        <a:t>小規模に取り出したトークン量のサンプル</a:t>
+                        <a:t>トークン量別の小規模サンプル</a:t>
                       </a:r>
                     </a:p>
                   </a:txBody>
@@ -22096,7 +22096,7 @@
                 <a:ea typeface="Noto Sans CJK JP"/>
                 <a:cs typeface="Noto Sans"/>
               </a:rPr>
-              <a:t>データと処理の比較実験を公開した点が特徴。初版15兆、現行カードは約18.5兆トークンを示す。</a:t>
+              <a:t>データと処理の比較実験も公開。初版は15兆、現行カードは約18.5兆トークンを示す。</a:t>
             </a:r>
           </a:p>
           <a:p>
@@ -23844,7 +23844,7 @@
                 <a:ea typeface="Noto Sans CJK JP"/>
                 <a:cs typeface="Noto Sans"/>
               </a:rPr>
-              <a:t>FineWeb-Eduには教育的価値のscore / int_scoreも付く [1, 2]。</a:t>
+              <a:t>FineWeb-Eduには教育的価値のscore / int_scoreも付与される [1, 2]。</a:t>
             </a:r>
           </a:p>
         </p:txBody>
@@ -26604,7 +26604,7 @@
                 <a:ea typeface="Noto Sans CJK JP"/>
                 <a:cs typeface="Noto Sans"/>
               </a:rPr>
-              <a:t>感情的な発言、固有名、顔文字が含まれる。会話的なWeb文も事前学習の対象になる [1]。</a:t>
+              <a:t>抜粋には感情的な発言や固有名が含まれる。会話的なWeb文も事前学習の対象になる [1]。</a:t>
             </a:r>
           </a:p>
         </p:txBody>
@@ -28438,7 +28438,7 @@
                 <a:ea typeface="Noto Sans CJK JP"/>
                 <a:cs typeface="Noto Sans"/>
               </a:rPr>
-              <a:t>チョコレートとチーズを組み合わせた商品について、ブランド名や発売の説明が載る [1]。</a:t>
+              <a:t>チョコレートとチーズを組み合わせた商品について、ブランド名や発売に関する説明が載る [1]。</a:t>
             </a:r>
           </a:p>
         </p:txBody>
@@ -31949,7 +31949,7 @@
                 <a:ea typeface="Noto Sans CJK JP"/>
                 <a:cs typeface="Noto Sans"/>
               </a:rPr>
-              <a:t>文書を英単語の5-gramへ分け、112個のハッシュを14組×8個にまとめる [1]。</a:t>
+              <a:t>文書を英単語の5-gramに分解し、112個のハッシュを14組×8個にまとめる [1]。</a:t>
             </a:r>
           </a:p>
           <a:p>
@@ -34261,7 +34261,7 @@
                 <a:ea typeface="Noto Sans CJK JP"/>
                 <a:cs typeface="Noto Sans"/>
               </a:rPr>
-              <a:t>配布token_countはGPT-2で数える [2]。</a:t>
+              <a:t>配布データのtoken_countはGPT-2で算出されている [2]。</a:t>
             </a:r>
           </a:p>
         </p:txBody>
@@ -40398,7 +40398,7 @@
                           <a:ea typeface="Noto Sans CJK JP"/>
                           <a:cs typeface="Noto Sans"/>
                         </a:rPr>
-                        <a:t>版 / 公開日</a:t>
+                        <a:t>バージョン / 公開日</a:t>
                       </a:r>
                     </a:p>
                   </a:txBody>
@@ -45348,7 +45348,7 @@
                 <a:ea typeface="Noto Sans CJK JP"/>
                 <a:cs typeface="Noto Sans"/>
               </a:rPr>
-              <a:t>FineWeb-Eduを合成教材とコードへ混ぜた、小規模言語モデルの開発記録。</a:t>
+              <a:t>FineWeb-Eduを合成教材やコードと混ぜた、小規模言語モデルの開発記録。</a:t>
             </a:r>
           </a:p>
         </p:txBody>

</xml_diff>

<commit_message>
slides(fineweb): refine Japanese wording and pair translations
</commit_message>
<xml_diff>
--- a/slides/datasets-in-10-minutes-fineweb.pptx
+++ b/slides/datasets-in-10-minutes-fineweb.pptx
@@ -9168,7 +9168,7 @@
                 <a:ea typeface="Noto Sans CJK JP"/>
                 <a:cs typeface="Noto Sans"/>
               </a:rPr>
-              <a:t>原著ではWETにメニューや定型文が多く残ることを確認し、WARCからTrafilaturaという本文抽出器で取り出した。</a:t>
+              <a:t>構築時にはWETにメニューや定型文が多く残ることを確認し、WARCからTrafilaturaという本文抽出器で取り出した。</a:t>
             </a:r>
           </a:p>
         </p:txBody>
@@ -10925,7 +10925,7 @@
                           <a:ea typeface="Noto Sans CJK JP"/>
                           <a:cs typeface="Noto Sans"/>
                         </a:rPr>
-                        <a:t>原著のFineWeb（2024）</a:t>
+                        <a:t>2024年のFineWeb</a:t>
                       </a:r>
                     </a:p>
                   </a:txBody>
@@ -11205,7 +11205,7 @@
                           <a:ea typeface="Noto Sans CJK JP"/>
                           <a:cs typeface="Noto Sans"/>
                         </a:rPr>
-                        <a:t>原著のFineWeb-Edu</a:t>
+                        <a:t>2024年のFineWeb-Edu</a:t>
                       </a:r>
                     </a:p>
                   </a:txBody>
@@ -11368,7 +11368,7 @@
                 <a:ea typeface="Noto Sans CJK JP"/>
                 <a:cs typeface="Noto Sans"/>
               </a:rPr>
-              <a:t>GPT-2で算定。原著は2013〜2024-04、現行設定は2025-06まで。Eduは原著の96クロールから選別 [1, 2]。</a:t>
+              <a:t>GPT-2で算定。論文の収集範囲は2013〜2024-04、現行設定は2025-06まで。Eduは同じ96クロールから選別 [1, 2]。</a:t>
             </a:r>
           </a:p>
         </p:txBody>
@@ -12321,7 +12321,6 @@
                 <a:latin typeface="Noto Sans"/>
                 <a:ea typeface="Noto Sans CJK JP"/>
                 <a:cs typeface="Noto Sans"/>
-                <a:hlinkClick r:id="rId3"/>
               </a:rPr>
               <a:t/>
             </a:r>
@@ -12433,7 +12432,7 @@
                 <a:ea typeface="Noto Sans CJK JP"/>
                 <a:cs typeface="Noto Sans"/>
               </a:rPr>
-              <a:t>46万文書をLLMで採点し、教育的な有用性の注釈を得る。原著は小中学校程度の知識を重視した [1]。</a:t>
+              <a:t>46万文書をLLMで採点し、教育的な有用性の注釈を得る。選別では小中学校程度の知識を重視した [1]。</a:t>
             </a:r>
           </a:p>
           <a:p>
@@ -13887,7 +13886,7 @@
                 <a:ea typeface="Noto Sans CJK JP"/>
                 <a:cs typeface="Noto Sans"/>
               </a:rPr>
-              <a:t>正解率 = 正解数 ÷ 設問数。この2問なら50%。原著では選択肢全文の尤度や長さ正規化を用い、複数課題を集計する [1]。</a:t>
+              <a:t>正解率 = 正解数 ÷ 設問数。この2問なら50%。公開時の評価では選択肢全文の尤度や長さ正規化を用い、複数課題を集計する [1]。</a:t>
             </a:r>
           </a:p>
         </p:txBody>
@@ -13996,7 +13995,7 @@
                 <a:ea typeface="Noto Sans CJK JP"/>
                 <a:cs typeface="Noto Sans"/>
               </a:rPr>
-              <a:t>原著で採用した知識・推論の評価課題</a:t>
+              <a:t>公開時に採用した知識・推論の評価課題</a:t>
             </a:r>
           </a:p>
         </p:txBody>
@@ -15683,7 +15682,7 @@
                 <a:ea typeface="Noto Sans CJK JP"/>
                 <a:cs typeface="Noto Sans"/>
               </a:rPr>
-              <a:t>原著v2における1.71Bモデル・350Bトークンでの比較 [1]。</a:t>
+              <a:t>論文バージョン2の1.71Bモデル・350Bトークンでの比較 [1]。</a:t>
             </a:r>
           </a:p>
         </p:txBody>
@@ -15792,7 +15791,7 @@
                 <a:ea typeface="Noto Sans CJK JP"/>
                 <a:cs typeface="Noto Sans"/>
               </a:rPr>
-              <a:t>原著の比較実験に用いたモデル構成</a:t>
+              <a:t>公開時の比較実験に用いたモデル構成</a:t>
             </a:r>
           </a:p>
         </p:txBody>
@@ -16798,7 +16797,7 @@
                 <a:ea typeface="Noto Sans CJK JP"/>
                 <a:cs typeface="Noto Sans"/>
               </a:rPr>
-              <a:t>原著掲載39分類から、増加側・減少側の上位3分類ずつを例示 [1]。</a:t>
+              <a:t>話題分析の39分類から、増加側・減少側の上位3分類ずつを例示 [1]。</a:t>
             </a:r>
           </a:p>
         </p:txBody>
@@ -17061,7 +17060,7 @@
                 <a:ea typeface="Noto Sans CJK JP"/>
                 <a:cs typeface="Noto Sans"/>
               </a:rPr>
-              <a:t>原著の図18は、構成比の差の絶対値が0.5ポイント以上の39分類を示す [1]。</a:t>
+              <a:t>Penedoら（2024）の図18は、構成比の差の絶対値が0.5ポイント以上の39分類を示す [1]。</a:t>
             </a:r>
           </a:p>
         </p:txBody>
@@ -31750,7 +31749,7 @@
                 <a:ea typeface="Noto Sans CJK JP"/>
                 <a:cs typeface="Noto Sans"/>
               </a:rPr>
-              <a:t>原著はWETにメニューなどが多く残ることを確認し、WARCからTrafilaturaで本文を抽出した。</a:t>
+              <a:t>構築時にはWETにメニューなどが多く残ることを確認し、WARCからTrafilaturaで本文を抽出した。</a:t>
             </a:r>
           </a:p>
         </p:txBody>
@@ -32247,7 +32246,7 @@
                           <a:ea typeface="Noto Sans CJK JP"/>
                           <a:cs typeface="Noto Sans"/>
                         </a:rPr>
-                        <a:t>原著v2の設定</a:t>
+                        <a:t>論文第2版の設定</a:t>
                       </a:r>
                     </a:p>
                   </a:txBody>
@@ -32743,7 +32742,7 @@
                 <a:ea typeface="Noto Sans CJK JP"/>
                 <a:cs typeface="Noto Sans"/>
               </a:rPr>
-              <a:t>原著は460k注釈、初期カードは500k表記 [1, 2]。</a:t>
+              <a:t>論文では460k件、初期カードでは500k件の注釈と表記 [1, 2]。</a:t>
             </a:r>
           </a:p>
         </p:txBody>
@@ -32900,7 +32899,7 @@
                 <a:ea typeface="Noto Sans CJK JP"/>
                 <a:cs typeface="Noto Sans"/>
               </a:rPr>
-              <a:t>初期公開CSVと原著v2の評価条件</a:t>
+              <a:t>初期公開CSVと論文バージョン2の評価条件</a:t>
             </a:r>
           </a:p>
         </p:txBody>
@@ -32977,7 +32976,7 @@
                 <a:ea typeface="Noto Sans CJK JP"/>
                 <a:cs typeface="Noto Sans"/>
               </a:rPr>
-              <a:t>FineWeb-EduのMMLU・ARC比較には、原著v2本文の丸め値を使用した [2]。</a:t>
+              <a:t>FineWeb-EduのMMLU・ARC比較には、論文バージョン2本文の丸め値を使用した [2]。</a:t>
             </a:r>
           </a:p>
         </p:txBody>
@@ -33276,7 +33275,7 @@
                           <a:ea typeface="Noto Sans CJK JP"/>
                           <a:cs typeface="Noto Sans"/>
                         </a:rPr>
-                        <a:t>話題（原著ラベルの和訳）</a:t>
+                        <a:t>話題（掲載ラベルの和訳）</a:t>
                       </a:r>
                     </a:p>
                   </a:txBody>
@@ -34257,7 +34256,7 @@
                           <a:ea typeface="Noto Sans CJK JP"/>
                           <a:cs typeface="Noto Sans"/>
                         </a:rPr>
-                        <a:t>話題（原著ラベルの和訳）</a:t>
+                        <a:t>話題（掲載ラベルの和訳）</a:t>
                       </a:r>
                     </a:p>
                   </a:txBody>
@@ -35541,7 +35540,7 @@
                           <a:ea typeface="Noto Sans CJK JP"/>
                           <a:cs typeface="Noto Sans"/>
                         </a:rPr>
-                        <a:t>話題（原著ラベルの和訳）</a:t>
+                        <a:t>話題（掲載ラベルの和訳）</a:t>
                       </a:r>
                     </a:p>
                   </a:txBody>
@@ -36522,7 +36521,7 @@
                           <a:ea typeface="Noto Sans CJK JP"/>
                           <a:cs typeface="Noto Sans"/>
                         </a:rPr>
-                        <a:t>話題（原著ラベルの和訳）</a:t>
+                        <a:t>話題（掲載ラベルの和訳）</a:t>
                       </a:r>
                     </a:p>
                   </a:txBody>
@@ -37503,7 +37502,7 @@
                           <a:ea typeface="Noto Sans CJK JP"/>
                           <a:cs typeface="Noto Sans"/>
                         </a:rPr>
-                        <a:t>話題（原著ラベルの和訳）</a:t>
+                        <a:t>話題（掲載ラベルの和訳）</a:t>
                       </a:r>
                     </a:p>
                   </a:txBody>
@@ -38484,7 +38483,7 @@
                           <a:ea typeface="Noto Sans CJK JP"/>
                           <a:cs typeface="Noto Sans"/>
                         </a:rPr>
-                        <a:t>話題（原著ラベルの和訳）</a:t>
+                        <a:t>話題（掲載ラベルの和訳）</a:t>
                       </a:r>
                     </a:p>
                   </a:txBody>
@@ -39465,7 +39464,7 @@
                           <a:ea typeface="Noto Sans CJK JP"/>
                           <a:cs typeface="Noto Sans"/>
                         </a:rPr>
-                        <a:t>話題（原著ラベルの和訳）</a:t>
+                        <a:t>話題（掲載ラベルの和訳）</a:t>
                       </a:r>
                     </a:p>
                   </a:txBody>
@@ -40100,7 +40099,7 @@
                 <a:ea typeface="Noto Sans CJK JP"/>
                 <a:cs typeface="Noto Sans"/>
               </a:rPr>
-              <a:t>原著の話題分析では、FineWebとEduから各50,000件を埋め込み、100個の密なクラスタを比較した [1]。</a:t>
+              <a:t>話題分析では、FineWebとEduから各50,000件を埋め込み、100個の密なクラスタを比較した [1]。</a:t>
             </a:r>
           </a:p>
           <a:p>
@@ -43331,7 +43330,7 @@
                 <a:ea typeface="Noto Sans CJK JP"/>
                 <a:cs typeface="Noto Sans"/>
               </a:rPr>
-              <a:t>Guilherme Penedoが第一著者、Thomas Wolfが最終著者。原著の所属表記はHugging Face [1]。</a:t>
+              <a:t>Guilherme Penedoが第一著者、Thomas Wolfが最終著者。発表時の所属はHugging Face [1]。</a:t>
             </a:r>
           </a:p>
           <a:p>
@@ -43761,7 +43760,7 @@
                 <a:ea typeface="Noto Sans CJK JP"/>
                 <a:cs typeface="Noto Sans"/>
               </a:rPr>
-              <a:t>T5の原著。英語WebコーパスC4と、テキスト変換に統一した学習・評価を提案する。</a:t>
+              <a:t>英語WebコーパスC4と、テキスト変換に統一した学習・評価を提案する。</a:t>
             </a:r>
           </a:p>
         </p:txBody>
@@ -44290,7 +44289,7 @@
                 <a:ea typeface="Noto Sans CJK JP"/>
                 <a:cs typeface="Noto Sans"/>
               </a:rPr>
-              <a:t>FineWebとEduの原著。抽出・重複除去・品質選別の比較実験を報告する。</a:t>
+              <a:t>抽出・重複除去・品質選別の比較実験を報告する。</a:t>
             </a:r>
           </a:p>
         </p:txBody>

</xml_diff>

<commit_message>
slides(fineweb): keep evaluation context independent of release timing
</commit_message>
<xml_diff>
--- a/slides/datasets-in-10-minutes-fineweb.pptx
+++ b/slides/datasets-in-10-minutes-fineweb.pptx
@@ -13886,7 +13886,7 @@
                 <a:ea typeface="Noto Sans CJK JP"/>
                 <a:cs typeface="Noto Sans"/>
               </a:rPr>
-              <a:t>正解率 = 正解数 ÷ 設問数。この2問なら50%。公開時の評価では選択肢全文の尤度や長さ正規化を用い、複数課題を集計する [1]。</a:t>
+              <a:t>正解率 = 正解数 ÷ 設問数。この2問なら50%。モデル評価では選択肢全文の尤度や長さ正規化を用い、複数課題を集計する [1]。</a:t>
             </a:r>
           </a:p>
         </p:txBody>
@@ -13995,7 +13995,7 @@
                 <a:ea typeface="Noto Sans CJK JP"/>
                 <a:cs typeface="Noto Sans"/>
               </a:rPr>
-              <a:t>公開時に採用した知識・推論の評価課題</a:t>
+              <a:t>採用した知識・推論の評価課題</a:t>
             </a:r>
           </a:p>
         </p:txBody>
@@ -15791,7 +15791,7 @@
                 <a:ea typeface="Noto Sans CJK JP"/>
                 <a:cs typeface="Noto Sans"/>
               </a:rPr>
-              <a:t>公開時の比較実験に用いたモデル構成</a:t>
+              <a:t>比較実験に用いたモデル構成</a:t>
             </a:r>
           </a:p>
         </p:txBody>

</xml_diff>